<commit_message>
docs: update faculty and instructor info from syllabus PDF
</commit_message>
<xml_diff>
--- a/BaoCao_Chude04_CleanArchitecture_DI.pptx
+++ b/BaoCao_Chude04_CleanArchitecture_DI.pptx
@@ -3411,15 +3411,28 @@
           <a:lstStyle/>
           <a:p>
             <a:pPr>
-              <a:defRPr sz="1600"/>
+              <a:defRPr sz="1500"/>
             </a:pPr>
             <a:r>
+              <a:t>Người hướng dẫn: TS. Nguyễn Duy Nhật Viễn</a:t>
+            </a:r>
+          </a:p>
+          <a:p>
+            <a:pPr>
+              <a:defRPr sz="1500"/>
+            </a:pPr>
+          </a:p>
+          <a:p>
+            <a:pPr>
+              <a:defRPr sz="1500"/>
+            </a:pPr>
+            <a:r>
               <a:t>SVTH:</a:t>
             </a:r>
           </a:p>
           <a:p>
             <a:pPr>
-              <a:defRPr sz="1600"/>
+              <a:defRPr sz="1500"/>
             </a:pPr>
             <a:r>
               <a:t>1. Thành viên 1 (Trưởng nhóm)</a:t>
@@ -3427,7 +3440,7 @@
           </a:p>
           <a:p>
             <a:pPr>
-              <a:defRPr sz="1600"/>
+              <a:defRPr sz="1500"/>
             </a:pPr>
             <a:r>
               <a:t>2. Thành viên 2</a:t>

</xml_diff>

<commit_message>
feat(ui): remove architecture info dialog and sync presentation slides
</commit_message>
<xml_diff>
--- a/BaoCao_Chude04_CleanArchitecture_DI.pptx
+++ b/BaoCao_Chude04_CleanArchitecture_DI.pptx
@@ -3996,7 +3996,7 @@
               </a:defRPr>
             </a:pPr>
             <a:r>
-              <a:t>• Dialog kiến trúc Clean Architecture hiển thị trực tiếp cấu trúc các tầng trên app.</a:t>
+              <a:t>• Tích hợp cử chỉ kéo để làm mới (Pull-to-Refresh) và nút làm mới dữ liệu nhanh chóng trên AppBar.</a:t>
             </a:r>
           </a:p>
           <a:p>
@@ -9729,7 +9729,7 @@
               </a:defRPr>
             </a:pPr>
             <a:r>
-              <a:t>• Hộp thoại kiến trúc (Architecture Dialog):</a:t>
+              <a:t>• Tương tác làm mới (Refresh Action):</a:t>
             </a:r>
           </a:p>
           <a:p>
@@ -9744,7 +9744,7 @@
               </a:defRPr>
             </a:pPr>
             <a:r>
-              <a:t>  Tích hợp sẵn Dialog giải thích cấu trúc 3 tầng Clean Architecture ngay trên AppBar giúp giảng viên dễ dàng kiểm tra trực tiếp.</a:t>
+              <a:t>  Tích hợp nút làm mới trên AppBar và cơ chế Pull-to-Refresh, gửi sự kiện MoviesRequested để cập nhật lại danh sách phim bất cứ lúc nào.</a:t>
             </a:r>
           </a:p>
         </p:txBody>

</xml_diff>